<commit_message>
Add live Streamlit demo link to README, report and slides
Co-Authored-By: Claude Sonnet 5.5 <noreply@anthropic.com>
</commit_message>
<xml_diff>
--- a/Presentation_Vehicle_Price_Prediction.pptx
+++ b/Presentation_Vehicle_Price_Prediction.pptx
@@ -4554,7 +4554,42 @@
       </p:sp>
       <p:sp>
         <p:nvSpPr>
-          <p:cNvPr id="6" name="Headline stat"/>
+          <p:cNvPr id="6" name="TextBox 5"/>
+          <p:cNvSpPr txBox="1"/>
+          <p:nvPr/>
+        </p:nvSpPr>
+        <p:spPr>
+          <a:xfrm>
+            <a:off x="731520" y="5806440"/>
+            <a:ext cx="10515600" cy="365760"/>
+          </a:xfrm>
+          <a:prstGeom prst="rect">
+            <a:avLst/>
+          </a:prstGeom>
+          <a:noFill/>
+        </p:spPr>
+        <p:txBody>
+          <a:bodyPr wrap="square" lIns="0" rIns="0" tIns="0" bIns="0" anchor="t">
+            <a:spAutoFit/>
+          </a:bodyPr>
+          <a:lstStyle/>
+          <a:p>
+            <a:pPr algn="l"/>
+            <a:r>
+              <a:rPr sz="1400" b="0" i="0">
+                <a:solidFill>
+                  <a:srgbClr val="F4A83A"/>
+                </a:solidFill>
+                <a:latin typeface="Calibri"/>
+              </a:rPr>
+              <a:t>Live demo: https://crazy-diya-ml-assignment-269136c-app-8yzt7l.streamlit.app/</a:t>
+            </a:r>
+          </a:p>
+        </p:txBody>
+      </p:sp>
+      <p:sp>
+        <p:nvSpPr>
+          <p:cNvPr id="7" name="Headline stat"/>
           <p:cNvSpPr/>
           <p:nvPr/>
         </p:nvSpPr>
@@ -4598,7 +4633,7 @@
       </p:sp>
       <p:sp>
         <p:nvSpPr>
-          <p:cNvPr id="7" name="TextBox 6"/>
+          <p:cNvPr id="8" name="TextBox 7"/>
           <p:cNvSpPr txBox="1"/>
           <p:nvPr/>
         </p:nvSpPr>
@@ -4633,7 +4668,7 @@
       </p:sp>
       <p:sp>
         <p:nvSpPr>
-          <p:cNvPr id="8" name="TextBox 7"/>
+          <p:cNvPr id="9" name="TextBox 8"/>
           <p:cNvSpPr txBox="1"/>
           <p:nvPr/>
         </p:nvSpPr>
@@ -5118,14 +5153,14 @@
       </p:sp>
       <p:sp>
         <p:nvSpPr>
-          <p:cNvPr id="13" name="TextBox 12"/>
+          <p:cNvPr id="13" name="Live demo link"/>
           <p:cNvSpPr txBox="1"/>
           <p:nvPr/>
         </p:nvSpPr>
         <p:spPr>
           <a:xfrm>
-            <a:off x="6903720" y="4800600"/>
-            <a:ext cx="4526280" cy="365760"/>
+            <a:off x="548640" y="6263640"/>
+            <a:ext cx="11091672" cy="365760"/>
           </a:xfrm>
           <a:prstGeom prst="rect">
             <a:avLst/>
@@ -5140,6 +5175,41 @@
           <a:p>
             <a:pPr algn="l"/>
             <a:r>
+              <a:rPr sz="1200" b="0" i="0">
+                <a:solidFill>
+                  <a:srgbClr val="5B6B7A"/>
+                </a:solidFill>
+                <a:latin typeface="Calibri"/>
+              </a:rPr>
+              <a:t>Live demo: https://crazy-diya-ml-assignment-269136c-app-8yzt7l.streamlit.app/</a:t>
+            </a:r>
+          </a:p>
+        </p:txBody>
+      </p:sp>
+      <p:sp>
+        <p:nvSpPr>
+          <p:cNvPr id="14" name="TextBox 13"/>
+          <p:cNvSpPr txBox="1"/>
+          <p:nvPr/>
+        </p:nvSpPr>
+        <p:spPr>
+          <a:xfrm>
+            <a:off x="6903720" y="4800600"/>
+            <a:ext cx="4526280" cy="365760"/>
+          </a:xfrm>
+          <a:prstGeom prst="rect">
+            <a:avLst/>
+          </a:prstGeom>
+          <a:noFill/>
+        </p:spPr>
+        <p:txBody>
+          <a:bodyPr wrap="square" lIns="0" rIns="0" tIns="0" bIns="0" anchor="t">
+            <a:spAutoFit/>
+          </a:bodyPr>
+          <a:lstStyle/>
+          <a:p>
+            <a:pPr algn="l"/>
+            <a:r>
               <a:rPr sz="1500" b="1" i="0">
                 <a:solidFill>
                   <a:srgbClr val="F4A83A"/>
@@ -5153,7 +5223,7 @@
       </p:sp>
       <p:sp>
         <p:nvSpPr>
-          <p:cNvPr id="14" name="TextBox 13"/>
+          <p:cNvPr id="15" name="TextBox 14"/>
           <p:cNvSpPr txBox="1"/>
           <p:nvPr/>
         </p:nvSpPr>

</xml_diff>

<commit_message>
Add Azure deployment docs, MLOps slide and report section; gate tolerance
Co-Authored-By: Claude Sonnet 5.5 <noreply@anthropic.com>
</commit_message>
<xml_diff>
--- a/Presentation_Vehicle_Price_Prediction.pptx
+++ b/Presentation_Vehicle_Price_Prediction.pptx
@@ -15,6 +15,7 @@
     <p:sldId id="263" r:id="rId15"/>
     <p:sldId id="264" r:id="rId16"/>
     <p:sldId id="265" r:id="rId17"/>
+    <p:sldId id="266" r:id="rId18"/>
   </p:sldIdLst>
   <p:sldSz cx="12191695" cy="6858000" type="screen4x3"/>
   <p:notesSz cx="6858000" cy="9144000"/>
@@ -838,6 +839,76 @@
           <a:lstStyle/>
           <a:p>
             <a:r>
+              <a:t>For the bonus I built an MLOps loop. Every push runs nine automated tests and a Docker health check. The image is published and runs on Azure Container Apps, and also on Streamlit Cloud. Every week the pipeline collects fresh ads, checks for drift with PSI and KS tests and measures live accuracy. If drift appears, it retrains a challenger and only promotes it if it is no worse than the current model on ads neither has seen, then opens a pull request for a human to approve.</a:t>
+            </a:r>
+          </a:p>
+        </p:txBody>
+      </p:sp>
+      <p:sp>
+        <p:nvSpPr>
+          <p:cNvPr id="4" name="Slide Number Placeholder 3"/>
+          <p:cNvSpPr>
+            <a:spLocks noGrp="1"/>
+          </p:cNvSpPr>
+          <p:nvPr>
+            <p:ph type="sldNum" idx="5" sz="quarter"/>
+          </p:nvPr>
+        </p:nvSpPr>
+        <p:spPr/>
+      </p:sp>
+    </p:spTree>
+  </p:cSld>
+  <p:clrMapOvr>
+    <a:masterClrMapping/>
+  </p:clrMapOvr>
+</p:notes>
+</file>
+
+<file path=ppt/notesSlides/notesSlide11.xml><?xml version="1.0" encoding="utf-8"?>
+<p:notes xmlns:a="http://schemas.openxmlformats.org/drawingml/2006/main" xmlns:p="http://schemas.openxmlformats.org/presentationml/2006/main" xmlns:r="http://schemas.openxmlformats.org/officeDocument/2006/relationships">
+  <p:cSld>
+    <p:spTree>
+      <p:nvGrpSpPr>
+        <p:cNvPr id="1" name=""/>
+        <p:cNvGrpSpPr/>
+        <p:nvPr/>
+      </p:nvGrpSpPr>
+      <p:grpSpPr>
+        <a:xfrm>
+          <a:off x="0" y="0"/>
+          <a:ext cx="0" cy="0"/>
+          <a:chOff x="0" y="0"/>
+          <a:chExt cx="0" cy="0"/>
+        </a:xfrm>
+      </p:grpSpPr>
+      <p:sp>
+        <p:nvSpPr>
+          <p:cNvPr id="2" name="Slide Image Placeholder 1"/>
+          <p:cNvSpPr>
+            <a:spLocks noGrp="1"/>
+          </p:cNvSpPr>
+          <p:nvPr>
+            <p:ph type="sldImg" idx="2"/>
+          </p:nvPr>
+        </p:nvSpPr>
+        <p:spPr/>
+      </p:sp>
+      <p:sp>
+        <p:nvSpPr>
+          <p:cNvPr id="3" name="Notes Placeholder 2"/>
+          <p:cNvSpPr>
+            <a:spLocks noGrp="1"/>
+          </p:cNvSpPr>
+          <p:nvPr>
+            <p:ph type="body" idx="3" sz="quarter"/>
+          </p:nvPr>
+        </p:nvSpPr>
+        <p:spPr/>
+        <p:txBody>
+          <a:bodyPr/>
+          <a:lstStyle/>
+          <a:p>
+            <a:r>
               <a:t>Here is the Streamlit app: pick the car's details, press Predict, and it returns an estimated price with a plus-or-minus 13 percent range. One car was kept out of all training; the model predicted 7.43 million against an actual 7.48 million - 0.6 percent off. Limits: asking prices, one website, 3,000 ads. Next: add a time-series component for market drift, more data sources, and MLOps deployment.</a:t>
             </a:r>
           </a:p>
@@ -4757,21 +4828,21 @@
                 </a:solidFill>
                 <a:latin typeface="Cambria"/>
               </a:rPr>
-              <a:t>Live demo, limits and next steps</a:t>
-            </a:r>
-          </a:p>
-        </p:txBody>
-      </p:sp>
-      <p:sp>
-        <p:nvSpPr>
-          <p:cNvPr id="3" name="App card"/>
+              <a:t>MLOps: tested, monitored and redeployed automatically</a:t>
+            </a:r>
+          </a:p>
+        </p:txBody>
+      </p:sp>
+      <p:sp>
+        <p:nvSpPr>
+          <p:cNvPr id="3" name="Deploy step 1"/>
           <p:cNvSpPr/>
           <p:nvPr/>
         </p:nvSpPr>
         <p:spPr>
           <a:xfrm>
-            <a:off x="548640" y="1417320"/>
-            <a:ext cx="5852160" cy="4754880"/>
+            <a:off x="548640" y="1508760"/>
+            <a:ext cx="2514600" cy="1554480"/>
           </a:xfrm>
           <a:prstGeom prst="roundRect">
             <a:avLst>
@@ -4810,40 +4881,121 @@
           </a:p>
         </p:txBody>
       </p:sp>
-      <p:pic>
-        <p:nvPicPr>
-          <p:cNvPr id="4" name="Streamlit app: inputs and predicted price" descr="Streamlit app: inputs and predicted price"/>
-          <p:cNvPicPr>
-            <a:picLocks noChangeAspect="1"/>
-          </p:cNvPicPr>
-          <p:nvPr/>
-        </p:nvPicPr>
-        <p:blipFill>
-          <a:blip r:embed="rId2"/>
-          <a:stretch>
-            <a:fillRect/>
-          </a:stretch>
-        </p:blipFill>
-        <p:spPr>
-          <a:xfrm>
-            <a:off x="640080" y="1508760"/>
-            <a:ext cx="5669280" cy="3798902"/>
+      <p:sp>
+        <p:nvSpPr>
+          <p:cNvPr id="4" name="TextBox 3"/>
+          <p:cNvSpPr txBox="1"/>
+          <p:nvPr/>
+        </p:nvSpPr>
+        <p:spPr>
+          <a:xfrm>
+            <a:off x="731520" y="1627632"/>
+            <a:ext cx="2148840" cy="365760"/>
           </a:xfrm>
           <a:prstGeom prst="rect">
             <a:avLst/>
           </a:prstGeom>
-        </p:spPr>
-      </p:pic>
-      <p:sp>
-        <p:nvSpPr>
-          <p:cNvPr id="5" name="Held-out car"/>
+          <a:noFill/>
+        </p:spPr>
+        <p:txBody>
+          <a:bodyPr wrap="square" lIns="0" rIns="0" tIns="0" bIns="0" anchor="t">
+            <a:spAutoFit/>
+          </a:bodyPr>
+          <a:lstStyle/>
+          <a:p>
+            <a:pPr algn="l"/>
+            <a:r>
+              <a:rPr sz="1800" b="1" i="0">
+                <a:solidFill>
+                  <a:srgbClr val="1B7F8C"/>
+                </a:solidFill>
+                <a:latin typeface="Calibri"/>
+              </a:rPr>
+              <a:t>Push or PR</a:t>
+            </a:r>
+          </a:p>
+        </p:txBody>
+      </p:sp>
+      <p:sp>
+        <p:nvSpPr>
+          <p:cNvPr id="5" name="TextBox 4"/>
+          <p:cNvSpPr txBox="1"/>
+          <p:nvPr/>
+        </p:nvSpPr>
+        <p:spPr>
+          <a:xfrm>
+            <a:off x="731520" y="2057400"/>
+            <a:ext cx="2148840" cy="960120"/>
+          </a:xfrm>
+          <a:prstGeom prst="rect">
+            <a:avLst/>
+          </a:prstGeom>
+          <a:noFill/>
+        </p:spPr>
+        <p:txBody>
+          <a:bodyPr wrap="square" lIns="0" rIns="0" tIns="0" bIns="0" anchor="t">
+            <a:spAutoFit/>
+          </a:bodyPr>
+          <a:lstStyle/>
+          <a:p>
+            <a:pPr algn="l"/>
+            <a:r>
+              <a:rPr sz="1400" b="0" i="0">
+                <a:solidFill>
+                  <a:srgbClr val="1F2933"/>
+                </a:solidFill>
+                <a:latin typeface="Calibri"/>
+              </a:rPr>
+              <a:t>GitHub</a:t>
+            </a:r>
+          </a:p>
+        </p:txBody>
+      </p:sp>
+      <p:sp>
+        <p:nvSpPr>
+          <p:cNvPr id="6" name="Arrow 1"/>
+          <p:cNvSpPr txBox="1"/>
+          <p:nvPr/>
+        </p:nvSpPr>
+        <p:spPr>
+          <a:xfrm>
+            <a:off x="3063240" y="2011680"/>
+            <a:ext cx="320040" cy="457200"/>
+          </a:xfrm>
+          <a:prstGeom prst="rect">
+            <a:avLst/>
+          </a:prstGeom>
+          <a:noFill/>
+        </p:spPr>
+        <p:txBody>
+          <a:bodyPr wrap="square" lIns="0" rIns="0" tIns="0" bIns="0" anchor="t">
+            <a:spAutoFit/>
+          </a:bodyPr>
+          <a:lstStyle/>
+          <a:p>
+            <a:pPr algn="ctr"/>
+            <a:r>
+              <a:rPr sz="2400" b="1" i="0">
+                <a:solidFill>
+                  <a:srgbClr val="F4A83A"/>
+                </a:solidFill>
+                <a:latin typeface="Calibri"/>
+              </a:rPr>
+              <a:t>&gt;</a:t>
+            </a:r>
+          </a:p>
+        </p:txBody>
+      </p:sp>
+      <p:sp>
+        <p:nvSpPr>
+          <p:cNvPr id="7" name="Deploy step 2"/>
           <p:cNvSpPr/>
           <p:nvPr/>
         </p:nvSpPr>
         <p:spPr>
           <a:xfrm>
-            <a:off x="6675120" y="1417320"/>
-            <a:ext cx="4965192" cy="1600200"/>
+            <a:off x="3383280" y="1508760"/>
+            <a:ext cx="2514600" cy="1554480"/>
           </a:xfrm>
           <a:prstGeom prst="roundRect">
             <a:avLst>
@@ -4884,14 +5036,14 @@
       </p:sp>
       <p:sp>
         <p:nvSpPr>
-          <p:cNvPr id="6" name="TextBox 5"/>
+          <p:cNvPr id="8" name="TextBox 7"/>
           <p:cNvSpPr txBox="1"/>
           <p:nvPr/>
         </p:nvSpPr>
         <p:spPr>
           <a:xfrm>
-            <a:off x="6903720" y="1508760"/>
-            <a:ext cx="4526280" cy="365760"/>
+            <a:off x="3566160" y="1627632"/>
+            <a:ext cx="2148840" cy="365760"/>
           </a:xfrm>
           <a:prstGeom prst="rect">
             <a:avLst/>
@@ -4906,27 +5058,27 @@
           <a:p>
             <a:pPr algn="l"/>
             <a:r>
-              <a:rPr sz="1500" b="1" i="0">
-                <a:solidFill>
-                  <a:srgbClr val="0F2A43"/>
+              <a:rPr sz="1800" b="1" i="0">
+                <a:solidFill>
+                  <a:srgbClr val="1B7F8C"/>
                 </a:solidFill>
                 <a:latin typeface="Calibri"/>
               </a:rPr>
-              <a:t>Held-out test car: Daihatsu Mira 2026</a:t>
-            </a:r>
-          </a:p>
-        </p:txBody>
-      </p:sp>
-      <p:sp>
-        <p:nvSpPr>
-          <p:cNvPr id="7" name="TextBox 6"/>
+              <a:t>CI</a:t>
+            </a:r>
+          </a:p>
+        </p:txBody>
+      </p:sp>
+      <p:sp>
+        <p:nvSpPr>
+          <p:cNvPr id="9" name="TextBox 8"/>
           <p:cNvSpPr txBox="1"/>
           <p:nvPr/>
         </p:nvSpPr>
         <p:spPr>
           <a:xfrm>
-            <a:off x="6903720" y="1920240"/>
-            <a:ext cx="4526280" cy="548640"/>
+            <a:off x="3566160" y="2057400"/>
+            <a:ext cx="2148840" cy="960120"/>
           </a:xfrm>
           <a:prstGeom prst="rect">
             <a:avLst/>
@@ -4941,27 +5093,27 @@
           <a:p>
             <a:pPr algn="l"/>
             <a:r>
-              <a:rPr sz="3200" b="1" i="0">
-                <a:solidFill>
-                  <a:srgbClr val="1B7F8C"/>
-                </a:solidFill>
-                <a:latin typeface="Cambria"/>
+              <a:rPr sz="1400" b="0" i="0">
+                <a:solidFill>
+                  <a:srgbClr val="1F2933"/>
+                </a:solidFill>
+                <a:latin typeface="Calibri"/>
               </a:rPr>
-              <a:t>−0.6% error</a:t>
-            </a:r>
-          </a:p>
-        </p:txBody>
-      </p:sp>
-      <p:sp>
-        <p:nvSpPr>
-          <p:cNvPr id="8" name="TextBox 7"/>
+              <a:t>9 tests + quality gate + Docker health check</a:t>
+            </a:r>
+          </a:p>
+        </p:txBody>
+      </p:sp>
+      <p:sp>
+        <p:nvSpPr>
+          <p:cNvPr id="10" name="Arrow 2"/>
           <p:cNvSpPr txBox="1"/>
           <p:nvPr/>
         </p:nvSpPr>
         <p:spPr>
           <a:xfrm>
-            <a:off x="6903720" y="2514600"/>
-            <a:ext cx="4526280" cy="411480"/>
+            <a:off x="5897880" y="2011680"/>
+            <a:ext cx="320040" cy="457200"/>
           </a:xfrm>
           <a:prstGeom prst="rect">
             <a:avLst/>
@@ -4974,29 +5126,29 @@
           </a:bodyPr>
           <a:lstStyle/>
           <a:p>
-            <a:pPr algn="l"/>
-            <a:r>
-              <a:rPr sz="1400" b="0" i="0">
-                <a:solidFill>
-                  <a:srgbClr val="1F2933"/>
+            <a:pPr algn="ctr"/>
+            <a:r>
+              <a:rPr sz="2400" b="1" i="0">
+                <a:solidFill>
+                  <a:srgbClr val="F4A83A"/>
                 </a:solidFill>
                 <a:latin typeface="Calibri"/>
               </a:rPr>
-              <a:t>Predicted LKR 7.43M vs actual LKR 7.48M</a:t>
-            </a:r>
-          </a:p>
-        </p:txBody>
-      </p:sp>
-      <p:sp>
-        <p:nvSpPr>
-          <p:cNvPr id="9" name="Limits"/>
+              <a:t>&gt;</a:t>
+            </a:r>
+          </a:p>
+        </p:txBody>
+      </p:sp>
+      <p:sp>
+        <p:nvSpPr>
+          <p:cNvPr id="11" name="Deploy step 3"/>
           <p:cNvSpPr/>
           <p:nvPr/>
         </p:nvSpPr>
         <p:spPr>
           <a:xfrm>
-            <a:off x="6675120" y="3200400"/>
-            <a:ext cx="4965192" cy="1325880"/>
+            <a:off x="6217920" y="1508760"/>
+            <a:ext cx="2514600" cy="1554480"/>
           </a:xfrm>
           <a:prstGeom prst="roundRect">
             <a:avLst>
@@ -5037,14 +5189,14 @@
       </p:sp>
       <p:sp>
         <p:nvSpPr>
-          <p:cNvPr id="10" name="TextBox 9"/>
+          <p:cNvPr id="12" name="TextBox 11"/>
           <p:cNvSpPr txBox="1"/>
           <p:nvPr/>
         </p:nvSpPr>
         <p:spPr>
           <a:xfrm>
-            <a:off x="6903720" y="3291840"/>
-            <a:ext cx="4526280" cy="365760"/>
+            <a:off x="6400800" y="1627632"/>
+            <a:ext cx="2148840" cy="365760"/>
           </a:xfrm>
           <a:prstGeom prst="rect">
             <a:avLst/>
@@ -5059,27 +5211,27 @@
           <a:p>
             <a:pPr algn="l"/>
             <a:r>
-              <a:rPr sz="1500" b="1" i="0">
-                <a:solidFill>
-                  <a:srgbClr val="0F2A43"/>
+              <a:rPr sz="1800" b="1" i="0">
+                <a:solidFill>
+                  <a:srgbClr val="1B7F8C"/>
                 </a:solidFill>
                 <a:latin typeface="Calibri"/>
               </a:rPr>
-              <a:t>Limits</a:t>
-            </a:r>
-          </a:p>
-        </p:txBody>
-      </p:sp>
-      <p:sp>
-        <p:nvSpPr>
-          <p:cNvPr id="11" name="TextBox 10"/>
+              <a:t>Image</a:t>
+            </a:r>
+          </a:p>
+        </p:txBody>
+      </p:sp>
+      <p:sp>
+        <p:nvSpPr>
+          <p:cNvPr id="13" name="TextBox 12"/>
           <p:cNvSpPr txBox="1"/>
           <p:nvPr/>
         </p:nvSpPr>
         <p:spPr>
           <a:xfrm>
-            <a:off x="6903720" y="3703320"/>
-            <a:ext cx="4526280" cy="777240"/>
+            <a:off x="6400800" y="2057400"/>
+            <a:ext cx="2148840" cy="960120"/>
           </a:xfrm>
           <a:prstGeom prst="rect">
             <a:avLst/>
@@ -5100,21 +5252,174 @@
                 </a:solidFill>
                 <a:latin typeface="Calibri"/>
               </a:rPr>
-              <a:t>Asking prices, one website, 3,000 ads, few comparables for rare cars</a:t>
-            </a:r>
-          </a:p>
-        </p:txBody>
-      </p:sp>
-      <p:sp>
-        <p:nvSpPr>
-          <p:cNvPr id="12" name="Next steps"/>
+              <a:t>GitHub Container Registry</a:t>
+            </a:r>
+          </a:p>
+        </p:txBody>
+      </p:sp>
+      <p:sp>
+        <p:nvSpPr>
+          <p:cNvPr id="14" name="Arrow 3"/>
+          <p:cNvSpPr txBox="1"/>
+          <p:nvPr/>
+        </p:nvSpPr>
+        <p:spPr>
+          <a:xfrm>
+            <a:off x="8732520" y="2011680"/>
+            <a:ext cx="320040" cy="457200"/>
+          </a:xfrm>
+          <a:prstGeom prst="rect">
+            <a:avLst/>
+          </a:prstGeom>
+          <a:noFill/>
+        </p:spPr>
+        <p:txBody>
+          <a:bodyPr wrap="square" lIns="0" rIns="0" tIns="0" bIns="0" anchor="t">
+            <a:spAutoFit/>
+          </a:bodyPr>
+          <a:lstStyle/>
+          <a:p>
+            <a:pPr algn="ctr"/>
+            <a:r>
+              <a:rPr sz="2400" b="1" i="0">
+                <a:solidFill>
+                  <a:srgbClr val="F4A83A"/>
+                </a:solidFill>
+                <a:latin typeface="Calibri"/>
+              </a:rPr>
+              <a:t>&gt;</a:t>
+            </a:r>
+          </a:p>
+        </p:txBody>
+      </p:sp>
+      <p:sp>
+        <p:nvSpPr>
+          <p:cNvPr id="15" name="Deploy step 4"/>
           <p:cNvSpPr/>
           <p:nvPr/>
         </p:nvSpPr>
         <p:spPr>
           <a:xfrm>
-            <a:off x="6675120" y="4709160"/>
-            <a:ext cx="4965192" cy="1463040"/>
+            <a:off x="9052560" y="1508760"/>
+            <a:ext cx="2514600" cy="1554480"/>
+          </a:xfrm>
+          <a:prstGeom prst="roundRect">
+            <a:avLst>
+              <a:gd name="adj" fmla="val 6000"/>
+            </a:avLst>
+          </a:prstGeom>
+          <a:solidFill>
+            <a:srgbClr val="FFFFFF"/>
+          </a:solidFill>
+          <a:ln w="9525">
+            <a:solidFill>
+              <a:srgbClr val="DDE3EA"/>
+            </a:solidFill>
+          </a:ln>
+          <a:effectLst/>
+        </p:spPr>
+        <p:style>
+          <a:lnRef idx="1">
+            <a:schemeClr val="accent1"/>
+          </a:lnRef>
+          <a:fillRef idx="3">
+            <a:schemeClr val="accent1"/>
+          </a:fillRef>
+          <a:effectRef idx="2">
+            <a:schemeClr val="accent1"/>
+          </a:effectRef>
+          <a:fontRef idx="minor">
+            <a:schemeClr val="lt1"/>
+          </a:fontRef>
+        </p:style>
+        <p:txBody>
+          <a:bodyPr rtlCol="0" anchor="ctr"/>
+          <a:lstStyle/>
+          <a:p>
+            <a:pPr algn="ctr"/>
+          </a:p>
+        </p:txBody>
+      </p:sp>
+      <p:sp>
+        <p:nvSpPr>
+          <p:cNvPr id="16" name="TextBox 15"/>
+          <p:cNvSpPr txBox="1"/>
+          <p:nvPr/>
+        </p:nvSpPr>
+        <p:spPr>
+          <a:xfrm>
+            <a:off x="9235440" y="1627632"/>
+            <a:ext cx="2148840" cy="365760"/>
+          </a:xfrm>
+          <a:prstGeom prst="rect">
+            <a:avLst/>
+          </a:prstGeom>
+          <a:noFill/>
+        </p:spPr>
+        <p:txBody>
+          <a:bodyPr wrap="square" lIns="0" rIns="0" tIns="0" bIns="0" anchor="t">
+            <a:spAutoFit/>
+          </a:bodyPr>
+          <a:lstStyle/>
+          <a:p>
+            <a:pPr algn="l"/>
+            <a:r>
+              <a:rPr sz="1800" b="1" i="0">
+                <a:solidFill>
+                  <a:srgbClr val="1B7F8C"/>
+                </a:solidFill>
+                <a:latin typeface="Calibri"/>
+              </a:rPr>
+              <a:t>Deploy</a:t>
+            </a:r>
+          </a:p>
+        </p:txBody>
+      </p:sp>
+      <p:sp>
+        <p:nvSpPr>
+          <p:cNvPr id="17" name="TextBox 16"/>
+          <p:cNvSpPr txBox="1"/>
+          <p:nvPr/>
+        </p:nvSpPr>
+        <p:spPr>
+          <a:xfrm>
+            <a:off x="9235440" y="2057400"/>
+            <a:ext cx="2148840" cy="960120"/>
+          </a:xfrm>
+          <a:prstGeom prst="rect">
+            <a:avLst/>
+          </a:prstGeom>
+          <a:noFill/>
+        </p:spPr>
+        <p:txBody>
+          <a:bodyPr wrap="square" lIns="0" rIns="0" tIns="0" bIns="0" anchor="t">
+            <a:spAutoFit/>
+          </a:bodyPr>
+          <a:lstStyle/>
+          <a:p>
+            <a:pPr algn="l"/>
+            <a:r>
+              <a:rPr sz="1400" b="0" i="0">
+                <a:solidFill>
+                  <a:srgbClr val="1F2933"/>
+                </a:solidFill>
+                <a:latin typeface="Calibri"/>
+              </a:rPr>
+              <a:t>Azure Container Apps + Streamlit Cloud</a:t>
+            </a:r>
+          </a:p>
+        </p:txBody>
+      </p:sp>
+      <p:sp>
+        <p:nvSpPr>
+          <p:cNvPr id="18" name="Monitor step 1"/>
+          <p:cNvSpPr/>
+          <p:nvPr/>
+        </p:nvSpPr>
+        <p:spPr>
+          <a:xfrm>
+            <a:off x="548640" y="3474720"/>
+            <a:ext cx="2514600" cy="1554480"/>
           </a:xfrm>
           <a:prstGeom prst="roundRect">
             <a:avLst>
@@ -5153,14 +5458,14 @@
       </p:sp>
       <p:sp>
         <p:nvSpPr>
-          <p:cNvPr id="13" name="Live demo link"/>
+          <p:cNvPr id="19" name="TextBox 18"/>
           <p:cNvSpPr txBox="1"/>
           <p:nvPr/>
         </p:nvSpPr>
         <p:spPr>
           <a:xfrm>
-            <a:off x="548640" y="6263640"/>
-            <a:ext cx="11091672" cy="365760"/>
+            <a:off x="731520" y="3593592"/>
+            <a:ext cx="2148840" cy="365760"/>
           </a:xfrm>
           <a:prstGeom prst="rect">
             <a:avLst/>
@@ -5175,27 +5480,27 @@
           <a:p>
             <a:pPr algn="l"/>
             <a:r>
-              <a:rPr sz="1200" b="0" i="0">
-                <a:solidFill>
-                  <a:srgbClr val="5B6B7A"/>
+              <a:rPr sz="1800" b="1" i="0">
+                <a:solidFill>
+                  <a:srgbClr val="F4A83A"/>
                 </a:solidFill>
                 <a:latin typeface="Calibri"/>
               </a:rPr>
-              <a:t>Live demo: https://crazy-diya-ml-assignment-269136c-app-8yzt7l.streamlit.app/</a:t>
-            </a:r>
-          </a:p>
-        </p:txBody>
-      </p:sp>
-      <p:sp>
-        <p:nvSpPr>
-          <p:cNvPr id="14" name="TextBox 13"/>
+              <a:t>Weekly monitor</a:t>
+            </a:r>
+          </a:p>
+        </p:txBody>
+      </p:sp>
+      <p:sp>
+        <p:nvSpPr>
+          <p:cNvPr id="20" name="TextBox 19"/>
           <p:cNvSpPr txBox="1"/>
           <p:nvPr/>
         </p:nvSpPr>
         <p:spPr>
           <a:xfrm>
-            <a:off x="6903720" y="4800600"/>
-            <a:ext cx="4526280" cy="365760"/>
+            <a:off x="731520" y="4023360"/>
+            <a:ext cx="2148840" cy="960120"/>
           </a:xfrm>
           <a:prstGeom prst="rect">
             <a:avLst/>
@@ -5210,6 +5515,1014 @@
           <a:p>
             <a:pPr algn="l"/>
             <a:r>
+              <a:rPr sz="1400" b="0" i="0">
+                <a:solidFill>
+                  <a:srgbClr val="FFFFFF"/>
+                </a:solidFill>
+                <a:latin typeface="Calibri"/>
+              </a:rPr>
+              <a:t>fresh ads vs training data: PSI, KS test, live MAPE</a:t>
+            </a:r>
+          </a:p>
+        </p:txBody>
+      </p:sp>
+      <p:sp>
+        <p:nvSpPr>
+          <p:cNvPr id="21" name="Arrow 5"/>
+          <p:cNvSpPr txBox="1"/>
+          <p:nvPr/>
+        </p:nvSpPr>
+        <p:spPr>
+          <a:xfrm>
+            <a:off x="3063240" y="3977639"/>
+            <a:ext cx="320040" cy="457200"/>
+          </a:xfrm>
+          <a:prstGeom prst="rect">
+            <a:avLst/>
+          </a:prstGeom>
+          <a:noFill/>
+        </p:spPr>
+        <p:txBody>
+          <a:bodyPr wrap="square" lIns="0" rIns="0" tIns="0" bIns="0" anchor="t">
+            <a:spAutoFit/>
+          </a:bodyPr>
+          <a:lstStyle/>
+          <a:p>
+            <a:pPr algn="ctr"/>
+            <a:r>
+              <a:rPr sz="2400" b="1" i="0">
+                <a:solidFill>
+                  <a:srgbClr val="F4A83A"/>
+                </a:solidFill>
+                <a:latin typeface="Calibri"/>
+              </a:rPr>
+              <a:t>&gt;</a:t>
+            </a:r>
+          </a:p>
+        </p:txBody>
+      </p:sp>
+      <p:sp>
+        <p:nvSpPr>
+          <p:cNvPr id="22" name="Monitor step 2"/>
+          <p:cNvSpPr/>
+          <p:nvPr/>
+        </p:nvSpPr>
+        <p:spPr>
+          <a:xfrm>
+            <a:off x="3383280" y="3474720"/>
+            <a:ext cx="2514600" cy="1554480"/>
+          </a:xfrm>
+          <a:prstGeom prst="roundRect">
+            <a:avLst>
+              <a:gd name="adj" fmla="val 6000"/>
+            </a:avLst>
+          </a:prstGeom>
+          <a:solidFill>
+            <a:srgbClr val="0F2A43"/>
+          </a:solidFill>
+          <a:ln>
+            <a:noFill/>
+          </a:ln>
+          <a:effectLst/>
+        </p:spPr>
+        <p:style>
+          <a:lnRef idx="1">
+            <a:schemeClr val="accent1"/>
+          </a:lnRef>
+          <a:fillRef idx="3">
+            <a:schemeClr val="accent1"/>
+          </a:fillRef>
+          <a:effectRef idx="2">
+            <a:schemeClr val="accent1"/>
+          </a:effectRef>
+          <a:fontRef idx="minor">
+            <a:schemeClr val="lt1"/>
+          </a:fontRef>
+        </p:style>
+        <p:txBody>
+          <a:bodyPr rtlCol="0" anchor="ctr"/>
+          <a:lstStyle/>
+          <a:p>
+            <a:pPr algn="ctr"/>
+          </a:p>
+        </p:txBody>
+      </p:sp>
+      <p:sp>
+        <p:nvSpPr>
+          <p:cNvPr id="23" name="TextBox 22"/>
+          <p:cNvSpPr txBox="1"/>
+          <p:nvPr/>
+        </p:nvSpPr>
+        <p:spPr>
+          <a:xfrm>
+            <a:off x="3566160" y="3593592"/>
+            <a:ext cx="2148840" cy="365760"/>
+          </a:xfrm>
+          <a:prstGeom prst="rect">
+            <a:avLst/>
+          </a:prstGeom>
+          <a:noFill/>
+        </p:spPr>
+        <p:txBody>
+          <a:bodyPr wrap="square" lIns="0" rIns="0" tIns="0" bIns="0" anchor="t">
+            <a:spAutoFit/>
+          </a:bodyPr>
+          <a:lstStyle/>
+          <a:p>
+            <a:pPr algn="l"/>
+            <a:r>
+              <a:rPr sz="1800" b="1" i="0">
+                <a:solidFill>
+                  <a:srgbClr val="F4A83A"/>
+                </a:solidFill>
+                <a:latin typeface="Calibri"/>
+              </a:rPr>
+              <a:t>Drift?</a:t>
+            </a:r>
+          </a:p>
+        </p:txBody>
+      </p:sp>
+      <p:sp>
+        <p:nvSpPr>
+          <p:cNvPr id="24" name="TextBox 23"/>
+          <p:cNvSpPr txBox="1"/>
+          <p:nvPr/>
+        </p:nvSpPr>
+        <p:spPr>
+          <a:xfrm>
+            <a:off x="3566160" y="4023360"/>
+            <a:ext cx="2148840" cy="960120"/>
+          </a:xfrm>
+          <a:prstGeom prst="rect">
+            <a:avLst/>
+          </a:prstGeom>
+          <a:noFill/>
+        </p:spPr>
+        <p:txBody>
+          <a:bodyPr wrap="square" lIns="0" rIns="0" tIns="0" bIns="0" anchor="t">
+            <a:spAutoFit/>
+          </a:bodyPr>
+          <a:lstStyle/>
+          <a:p>
+            <a:pPr algn="l"/>
+            <a:r>
+              <a:rPr sz="1400" b="0" i="0">
+                <a:solidFill>
+                  <a:srgbClr val="FFFFFF"/>
+                </a:solidFill>
+                <a:latin typeface="Calibri"/>
+              </a:rPr>
+              <a:t>if yes, retrain a challenger on old + fresh data</a:t>
+            </a:r>
+          </a:p>
+        </p:txBody>
+      </p:sp>
+      <p:sp>
+        <p:nvSpPr>
+          <p:cNvPr id="25" name="Arrow 6"/>
+          <p:cNvSpPr txBox="1"/>
+          <p:nvPr/>
+        </p:nvSpPr>
+        <p:spPr>
+          <a:xfrm>
+            <a:off x="5897880" y="3977639"/>
+            <a:ext cx="320040" cy="457200"/>
+          </a:xfrm>
+          <a:prstGeom prst="rect">
+            <a:avLst/>
+          </a:prstGeom>
+          <a:noFill/>
+        </p:spPr>
+        <p:txBody>
+          <a:bodyPr wrap="square" lIns="0" rIns="0" tIns="0" bIns="0" anchor="t">
+            <a:spAutoFit/>
+          </a:bodyPr>
+          <a:lstStyle/>
+          <a:p>
+            <a:pPr algn="ctr"/>
+            <a:r>
+              <a:rPr sz="2400" b="1" i="0">
+                <a:solidFill>
+                  <a:srgbClr val="F4A83A"/>
+                </a:solidFill>
+                <a:latin typeface="Calibri"/>
+              </a:rPr>
+              <a:t>&gt;</a:t>
+            </a:r>
+          </a:p>
+        </p:txBody>
+      </p:sp>
+      <p:sp>
+        <p:nvSpPr>
+          <p:cNvPr id="26" name="Monitor step 3"/>
+          <p:cNvSpPr/>
+          <p:nvPr/>
+        </p:nvSpPr>
+        <p:spPr>
+          <a:xfrm>
+            <a:off x="6217920" y="3474720"/>
+            <a:ext cx="2514600" cy="1554480"/>
+          </a:xfrm>
+          <a:prstGeom prst="roundRect">
+            <a:avLst>
+              <a:gd name="adj" fmla="val 6000"/>
+            </a:avLst>
+          </a:prstGeom>
+          <a:solidFill>
+            <a:srgbClr val="0F2A43"/>
+          </a:solidFill>
+          <a:ln>
+            <a:noFill/>
+          </a:ln>
+          <a:effectLst/>
+        </p:spPr>
+        <p:style>
+          <a:lnRef idx="1">
+            <a:schemeClr val="accent1"/>
+          </a:lnRef>
+          <a:fillRef idx="3">
+            <a:schemeClr val="accent1"/>
+          </a:fillRef>
+          <a:effectRef idx="2">
+            <a:schemeClr val="accent1"/>
+          </a:effectRef>
+          <a:fontRef idx="minor">
+            <a:schemeClr val="lt1"/>
+          </a:fontRef>
+        </p:style>
+        <p:txBody>
+          <a:bodyPr rtlCol="0" anchor="ctr"/>
+          <a:lstStyle/>
+          <a:p>
+            <a:pPr algn="ctr"/>
+          </a:p>
+        </p:txBody>
+      </p:sp>
+      <p:sp>
+        <p:nvSpPr>
+          <p:cNvPr id="27" name="TextBox 26"/>
+          <p:cNvSpPr txBox="1"/>
+          <p:nvPr/>
+        </p:nvSpPr>
+        <p:spPr>
+          <a:xfrm>
+            <a:off x="6400800" y="3593592"/>
+            <a:ext cx="2148840" cy="365760"/>
+          </a:xfrm>
+          <a:prstGeom prst="rect">
+            <a:avLst/>
+          </a:prstGeom>
+          <a:noFill/>
+        </p:spPr>
+        <p:txBody>
+          <a:bodyPr wrap="square" lIns="0" rIns="0" tIns="0" bIns="0" anchor="t">
+            <a:spAutoFit/>
+          </a:bodyPr>
+          <a:lstStyle/>
+          <a:p>
+            <a:pPr algn="l"/>
+            <a:r>
+              <a:rPr sz="1800" b="1" i="0">
+                <a:solidFill>
+                  <a:srgbClr val="F4A83A"/>
+                </a:solidFill>
+                <a:latin typeface="Calibri"/>
+              </a:rPr>
+              <a:t>Quality gate</a:t>
+            </a:r>
+          </a:p>
+        </p:txBody>
+      </p:sp>
+      <p:sp>
+        <p:nvSpPr>
+          <p:cNvPr id="28" name="TextBox 27"/>
+          <p:cNvSpPr txBox="1"/>
+          <p:nvPr/>
+        </p:nvSpPr>
+        <p:spPr>
+          <a:xfrm>
+            <a:off x="6400800" y="4023360"/>
+            <a:ext cx="2148840" cy="960120"/>
+          </a:xfrm>
+          <a:prstGeom prst="rect">
+            <a:avLst/>
+          </a:prstGeom>
+          <a:noFill/>
+        </p:spPr>
+        <p:txBody>
+          <a:bodyPr wrap="square" lIns="0" rIns="0" tIns="0" bIns="0" anchor="t">
+            <a:spAutoFit/>
+          </a:bodyPr>
+          <a:lstStyle/>
+          <a:p>
+            <a:pPr algn="l"/>
+            <a:r>
+              <a:rPr sz="1400" b="0" i="0">
+                <a:solidFill>
+                  <a:srgbClr val="FFFFFF"/>
+                </a:solidFill>
+                <a:latin typeface="Calibri"/>
+              </a:rPr>
+              <a:t>challenger vs champion on ads neither has seen</a:t>
+            </a:r>
+          </a:p>
+        </p:txBody>
+      </p:sp>
+      <p:sp>
+        <p:nvSpPr>
+          <p:cNvPr id="29" name="Arrow 7"/>
+          <p:cNvSpPr txBox="1"/>
+          <p:nvPr/>
+        </p:nvSpPr>
+        <p:spPr>
+          <a:xfrm>
+            <a:off x="8732520" y="3977639"/>
+            <a:ext cx="320040" cy="457200"/>
+          </a:xfrm>
+          <a:prstGeom prst="rect">
+            <a:avLst/>
+          </a:prstGeom>
+          <a:noFill/>
+        </p:spPr>
+        <p:txBody>
+          <a:bodyPr wrap="square" lIns="0" rIns="0" tIns="0" bIns="0" anchor="t">
+            <a:spAutoFit/>
+          </a:bodyPr>
+          <a:lstStyle/>
+          <a:p>
+            <a:pPr algn="ctr"/>
+            <a:r>
+              <a:rPr sz="2400" b="1" i="0">
+                <a:solidFill>
+                  <a:srgbClr val="F4A83A"/>
+                </a:solidFill>
+                <a:latin typeface="Calibri"/>
+              </a:rPr>
+              <a:t>&gt;</a:t>
+            </a:r>
+          </a:p>
+        </p:txBody>
+      </p:sp>
+      <p:sp>
+        <p:nvSpPr>
+          <p:cNvPr id="30" name="Monitor step 4"/>
+          <p:cNvSpPr/>
+          <p:nvPr/>
+        </p:nvSpPr>
+        <p:spPr>
+          <a:xfrm>
+            <a:off x="9052560" y="3474720"/>
+            <a:ext cx="2514600" cy="1554480"/>
+          </a:xfrm>
+          <a:prstGeom prst="roundRect">
+            <a:avLst>
+              <a:gd name="adj" fmla="val 6000"/>
+            </a:avLst>
+          </a:prstGeom>
+          <a:solidFill>
+            <a:srgbClr val="0F2A43"/>
+          </a:solidFill>
+          <a:ln>
+            <a:noFill/>
+          </a:ln>
+          <a:effectLst/>
+        </p:spPr>
+        <p:style>
+          <a:lnRef idx="1">
+            <a:schemeClr val="accent1"/>
+          </a:lnRef>
+          <a:fillRef idx="3">
+            <a:schemeClr val="accent1"/>
+          </a:fillRef>
+          <a:effectRef idx="2">
+            <a:schemeClr val="accent1"/>
+          </a:effectRef>
+          <a:fontRef idx="minor">
+            <a:schemeClr val="lt1"/>
+          </a:fontRef>
+        </p:style>
+        <p:txBody>
+          <a:bodyPr rtlCol="0" anchor="ctr"/>
+          <a:lstStyle/>
+          <a:p>
+            <a:pPr algn="ctr"/>
+          </a:p>
+        </p:txBody>
+      </p:sp>
+      <p:sp>
+        <p:nvSpPr>
+          <p:cNvPr id="31" name="TextBox 30"/>
+          <p:cNvSpPr txBox="1"/>
+          <p:nvPr/>
+        </p:nvSpPr>
+        <p:spPr>
+          <a:xfrm>
+            <a:off x="9235440" y="3593592"/>
+            <a:ext cx="2148840" cy="365760"/>
+          </a:xfrm>
+          <a:prstGeom prst="rect">
+            <a:avLst/>
+          </a:prstGeom>
+          <a:noFill/>
+        </p:spPr>
+        <p:txBody>
+          <a:bodyPr wrap="square" lIns="0" rIns="0" tIns="0" bIns="0" anchor="t">
+            <a:spAutoFit/>
+          </a:bodyPr>
+          <a:lstStyle/>
+          <a:p>
+            <a:pPr algn="l"/>
+            <a:r>
+              <a:rPr sz="1800" b="1" i="0">
+                <a:solidFill>
+                  <a:srgbClr val="F4A83A"/>
+                </a:solidFill>
+                <a:latin typeface="Calibri"/>
+              </a:rPr>
+              <a:t>Pull request</a:t>
+            </a:r>
+          </a:p>
+        </p:txBody>
+      </p:sp>
+      <p:sp>
+        <p:nvSpPr>
+          <p:cNvPr id="32" name="TextBox 31"/>
+          <p:cNvSpPr txBox="1"/>
+          <p:nvPr/>
+        </p:nvSpPr>
+        <p:spPr>
+          <a:xfrm>
+            <a:off x="9235440" y="4023360"/>
+            <a:ext cx="2148840" cy="960120"/>
+          </a:xfrm>
+          <a:prstGeom prst="rect">
+            <a:avLst/>
+          </a:prstGeom>
+          <a:noFill/>
+        </p:spPr>
+        <p:txBody>
+          <a:bodyPr wrap="square" lIns="0" rIns="0" tIns="0" bIns="0" anchor="t">
+            <a:spAutoFit/>
+          </a:bodyPr>
+          <a:lstStyle/>
+          <a:p>
+            <a:pPr algn="l"/>
+            <a:r>
+              <a:rPr sz="1400" b="0" i="0">
+                <a:solidFill>
+                  <a:srgbClr val="FFFFFF"/>
+                </a:solidFill>
+                <a:latin typeface="Calibri"/>
+              </a:rPr>
+              <a:t>a human approves, merge redeploys</a:t>
+            </a:r>
+          </a:p>
+        </p:txBody>
+      </p:sp>
+      <p:sp>
+        <p:nvSpPr>
+          <p:cNvPr id="33" name="TextBox 32"/>
+          <p:cNvSpPr txBox="1"/>
+          <p:nvPr/>
+        </p:nvSpPr>
+        <p:spPr>
+          <a:xfrm>
+            <a:off x="548640" y="5349240"/>
+            <a:ext cx="11091672" cy="822960"/>
+          </a:xfrm>
+          <a:prstGeom prst="rect">
+            <a:avLst/>
+          </a:prstGeom>
+          <a:noFill/>
+        </p:spPr>
+        <p:txBody>
+          <a:bodyPr wrap="square" lIns="0" rIns="0" tIns="0" bIns="0" anchor="t">
+            <a:spAutoFit/>
+          </a:bodyPr>
+          <a:lstStyle/>
+          <a:p>
+            <a:pPr algn="l"/>
+            <a:r>
+              <a:rPr sz="1500" b="0" i="0">
+                <a:solidFill>
+                  <a:srgbClr val="1F2933"/>
+                </a:solidFill>
+                <a:latin typeface="Calibri"/>
+              </a:rPr>
+              <a:t>On 200 fresh ads the live model scored MAPE 9.4% with no drift. In a retrain test the challenger beat the champion (log-RMSE 0.1285 vs 0.1305) and was promoted. Azure runs at about zero cost thanks to scale-to-zero.</a:t>
+            </a:r>
+          </a:p>
+        </p:txBody>
+      </p:sp>
+    </p:spTree>
+  </p:cSld>
+  <p:clrMapOvr>
+    <a:masterClrMapping/>
+  </p:clrMapOvr>
+</p:sld>
+</file>
+
+<file path=ppt/slides/slide11.xml><?xml version="1.0" encoding="utf-8"?>
+<p:sld xmlns:a="http://schemas.openxmlformats.org/drawingml/2006/main" xmlns:p="http://schemas.openxmlformats.org/presentationml/2006/main" xmlns:r="http://schemas.openxmlformats.org/officeDocument/2006/relationships">
+  <p:cSld>
+    <p:bg>
+      <p:bgPr>
+        <a:solidFill>
+          <a:srgbClr val="F4F6F8"/>
+        </a:solidFill>
+        <a:effectLst/>
+      </p:bgPr>
+    </p:bg>
+    <p:spTree>
+      <p:nvGrpSpPr>
+        <p:cNvPr id="1" name=""/>
+        <p:cNvGrpSpPr/>
+        <p:nvPr/>
+      </p:nvGrpSpPr>
+      <p:grpSpPr/>
+      <p:sp>
+        <p:nvSpPr>
+          <p:cNvPr id="2" name="Title"/>
+          <p:cNvSpPr txBox="1"/>
+          <p:nvPr/>
+        </p:nvSpPr>
+        <p:spPr>
+          <a:xfrm>
+            <a:off x="548640" y="365760"/>
+            <a:ext cx="11094415" cy="868680"/>
+          </a:xfrm>
+          <a:prstGeom prst="rect">
+            <a:avLst/>
+          </a:prstGeom>
+          <a:noFill/>
+        </p:spPr>
+        <p:txBody>
+          <a:bodyPr wrap="square" lIns="0" rIns="0" tIns="0" bIns="0" anchor="ctr">
+            <a:spAutoFit/>
+          </a:bodyPr>
+          <a:lstStyle/>
+          <a:p>
+            <a:pPr algn="l"/>
+            <a:r>
+              <a:rPr sz="3200" b="1" i="0">
+                <a:solidFill>
+                  <a:srgbClr val="0F2A43"/>
+                </a:solidFill>
+                <a:latin typeface="Cambria"/>
+              </a:rPr>
+              <a:t>Live demo, limits and next steps</a:t>
+            </a:r>
+          </a:p>
+        </p:txBody>
+      </p:sp>
+      <p:sp>
+        <p:nvSpPr>
+          <p:cNvPr id="3" name="App card"/>
+          <p:cNvSpPr/>
+          <p:nvPr/>
+        </p:nvSpPr>
+        <p:spPr>
+          <a:xfrm>
+            <a:off x="548640" y="1417320"/>
+            <a:ext cx="5852160" cy="4754880"/>
+          </a:xfrm>
+          <a:prstGeom prst="roundRect">
+            <a:avLst>
+              <a:gd name="adj" fmla="val 6000"/>
+            </a:avLst>
+          </a:prstGeom>
+          <a:solidFill>
+            <a:srgbClr val="FFFFFF"/>
+          </a:solidFill>
+          <a:ln w="9525">
+            <a:solidFill>
+              <a:srgbClr val="DDE3EA"/>
+            </a:solidFill>
+          </a:ln>
+          <a:effectLst/>
+        </p:spPr>
+        <p:style>
+          <a:lnRef idx="1">
+            <a:schemeClr val="accent1"/>
+          </a:lnRef>
+          <a:fillRef idx="3">
+            <a:schemeClr val="accent1"/>
+          </a:fillRef>
+          <a:effectRef idx="2">
+            <a:schemeClr val="accent1"/>
+          </a:effectRef>
+          <a:fontRef idx="minor">
+            <a:schemeClr val="lt1"/>
+          </a:fontRef>
+        </p:style>
+        <p:txBody>
+          <a:bodyPr rtlCol="0" anchor="ctr"/>
+          <a:lstStyle/>
+          <a:p>
+            <a:pPr algn="ctr"/>
+          </a:p>
+        </p:txBody>
+      </p:sp>
+      <p:pic>
+        <p:nvPicPr>
+          <p:cNvPr id="4" name="Streamlit app: inputs and predicted price" descr="Streamlit app: inputs and predicted price"/>
+          <p:cNvPicPr>
+            <a:picLocks noChangeAspect="1"/>
+          </p:cNvPicPr>
+          <p:nvPr/>
+        </p:nvPicPr>
+        <p:blipFill>
+          <a:blip r:embed="rId2"/>
+          <a:stretch>
+            <a:fillRect/>
+          </a:stretch>
+        </p:blipFill>
+        <p:spPr>
+          <a:xfrm>
+            <a:off x="640080" y="1508760"/>
+            <a:ext cx="5669280" cy="3798902"/>
+          </a:xfrm>
+          <a:prstGeom prst="rect">
+            <a:avLst/>
+          </a:prstGeom>
+        </p:spPr>
+      </p:pic>
+      <p:sp>
+        <p:nvSpPr>
+          <p:cNvPr id="5" name="Held-out car"/>
+          <p:cNvSpPr/>
+          <p:nvPr/>
+        </p:nvSpPr>
+        <p:spPr>
+          <a:xfrm>
+            <a:off x="6675120" y="1417320"/>
+            <a:ext cx="4965192" cy="1600200"/>
+          </a:xfrm>
+          <a:prstGeom prst="roundRect">
+            <a:avLst>
+              <a:gd name="adj" fmla="val 6000"/>
+            </a:avLst>
+          </a:prstGeom>
+          <a:solidFill>
+            <a:srgbClr val="FFFFFF"/>
+          </a:solidFill>
+          <a:ln w="9525">
+            <a:solidFill>
+              <a:srgbClr val="DDE3EA"/>
+            </a:solidFill>
+          </a:ln>
+          <a:effectLst/>
+        </p:spPr>
+        <p:style>
+          <a:lnRef idx="1">
+            <a:schemeClr val="accent1"/>
+          </a:lnRef>
+          <a:fillRef idx="3">
+            <a:schemeClr val="accent1"/>
+          </a:fillRef>
+          <a:effectRef idx="2">
+            <a:schemeClr val="accent1"/>
+          </a:effectRef>
+          <a:fontRef idx="minor">
+            <a:schemeClr val="lt1"/>
+          </a:fontRef>
+        </p:style>
+        <p:txBody>
+          <a:bodyPr rtlCol="0" anchor="ctr"/>
+          <a:lstStyle/>
+          <a:p>
+            <a:pPr algn="ctr"/>
+          </a:p>
+        </p:txBody>
+      </p:sp>
+      <p:sp>
+        <p:nvSpPr>
+          <p:cNvPr id="6" name="TextBox 5"/>
+          <p:cNvSpPr txBox="1"/>
+          <p:nvPr/>
+        </p:nvSpPr>
+        <p:spPr>
+          <a:xfrm>
+            <a:off x="6903720" y="1508760"/>
+            <a:ext cx="4526280" cy="365760"/>
+          </a:xfrm>
+          <a:prstGeom prst="rect">
+            <a:avLst/>
+          </a:prstGeom>
+          <a:noFill/>
+        </p:spPr>
+        <p:txBody>
+          <a:bodyPr wrap="square" lIns="0" rIns="0" tIns="0" bIns="0" anchor="t">
+            <a:spAutoFit/>
+          </a:bodyPr>
+          <a:lstStyle/>
+          <a:p>
+            <a:pPr algn="l"/>
+            <a:r>
+              <a:rPr sz="1500" b="1" i="0">
+                <a:solidFill>
+                  <a:srgbClr val="0F2A43"/>
+                </a:solidFill>
+                <a:latin typeface="Calibri"/>
+              </a:rPr>
+              <a:t>Held-out test car: Daihatsu Mira 2026</a:t>
+            </a:r>
+          </a:p>
+        </p:txBody>
+      </p:sp>
+      <p:sp>
+        <p:nvSpPr>
+          <p:cNvPr id="7" name="TextBox 6"/>
+          <p:cNvSpPr txBox="1"/>
+          <p:nvPr/>
+        </p:nvSpPr>
+        <p:spPr>
+          <a:xfrm>
+            <a:off x="6903720" y="1920240"/>
+            <a:ext cx="4526280" cy="548640"/>
+          </a:xfrm>
+          <a:prstGeom prst="rect">
+            <a:avLst/>
+          </a:prstGeom>
+          <a:noFill/>
+        </p:spPr>
+        <p:txBody>
+          <a:bodyPr wrap="square" lIns="0" rIns="0" tIns="0" bIns="0" anchor="t">
+            <a:spAutoFit/>
+          </a:bodyPr>
+          <a:lstStyle/>
+          <a:p>
+            <a:pPr algn="l"/>
+            <a:r>
+              <a:rPr sz="3200" b="1" i="0">
+                <a:solidFill>
+                  <a:srgbClr val="1B7F8C"/>
+                </a:solidFill>
+                <a:latin typeface="Cambria"/>
+              </a:rPr>
+              <a:t>−0.6% error</a:t>
+            </a:r>
+          </a:p>
+        </p:txBody>
+      </p:sp>
+      <p:sp>
+        <p:nvSpPr>
+          <p:cNvPr id="8" name="TextBox 7"/>
+          <p:cNvSpPr txBox="1"/>
+          <p:nvPr/>
+        </p:nvSpPr>
+        <p:spPr>
+          <a:xfrm>
+            <a:off x="6903720" y="2514600"/>
+            <a:ext cx="4526280" cy="411480"/>
+          </a:xfrm>
+          <a:prstGeom prst="rect">
+            <a:avLst/>
+          </a:prstGeom>
+          <a:noFill/>
+        </p:spPr>
+        <p:txBody>
+          <a:bodyPr wrap="square" lIns="0" rIns="0" tIns="0" bIns="0" anchor="t">
+            <a:spAutoFit/>
+          </a:bodyPr>
+          <a:lstStyle/>
+          <a:p>
+            <a:pPr algn="l"/>
+            <a:r>
+              <a:rPr sz="1400" b="0" i="0">
+                <a:solidFill>
+                  <a:srgbClr val="1F2933"/>
+                </a:solidFill>
+                <a:latin typeface="Calibri"/>
+              </a:rPr>
+              <a:t>Predicted LKR 7.43M vs actual LKR 7.48M</a:t>
+            </a:r>
+          </a:p>
+        </p:txBody>
+      </p:sp>
+      <p:sp>
+        <p:nvSpPr>
+          <p:cNvPr id="9" name="Limits"/>
+          <p:cNvSpPr/>
+          <p:nvPr/>
+        </p:nvSpPr>
+        <p:spPr>
+          <a:xfrm>
+            <a:off x="6675120" y="3200400"/>
+            <a:ext cx="4965192" cy="1325880"/>
+          </a:xfrm>
+          <a:prstGeom prst="roundRect">
+            <a:avLst>
+              <a:gd name="adj" fmla="val 6000"/>
+            </a:avLst>
+          </a:prstGeom>
+          <a:solidFill>
+            <a:srgbClr val="FFFFFF"/>
+          </a:solidFill>
+          <a:ln w="9525">
+            <a:solidFill>
+              <a:srgbClr val="DDE3EA"/>
+            </a:solidFill>
+          </a:ln>
+          <a:effectLst/>
+        </p:spPr>
+        <p:style>
+          <a:lnRef idx="1">
+            <a:schemeClr val="accent1"/>
+          </a:lnRef>
+          <a:fillRef idx="3">
+            <a:schemeClr val="accent1"/>
+          </a:fillRef>
+          <a:effectRef idx="2">
+            <a:schemeClr val="accent1"/>
+          </a:effectRef>
+          <a:fontRef idx="minor">
+            <a:schemeClr val="lt1"/>
+          </a:fontRef>
+        </p:style>
+        <p:txBody>
+          <a:bodyPr rtlCol="0" anchor="ctr"/>
+          <a:lstStyle/>
+          <a:p>
+            <a:pPr algn="ctr"/>
+          </a:p>
+        </p:txBody>
+      </p:sp>
+      <p:sp>
+        <p:nvSpPr>
+          <p:cNvPr id="10" name="TextBox 9"/>
+          <p:cNvSpPr txBox="1"/>
+          <p:nvPr/>
+        </p:nvSpPr>
+        <p:spPr>
+          <a:xfrm>
+            <a:off x="6903720" y="3291840"/>
+            <a:ext cx="4526280" cy="365760"/>
+          </a:xfrm>
+          <a:prstGeom prst="rect">
+            <a:avLst/>
+          </a:prstGeom>
+          <a:noFill/>
+        </p:spPr>
+        <p:txBody>
+          <a:bodyPr wrap="square" lIns="0" rIns="0" tIns="0" bIns="0" anchor="t">
+            <a:spAutoFit/>
+          </a:bodyPr>
+          <a:lstStyle/>
+          <a:p>
+            <a:pPr algn="l"/>
+            <a:r>
+              <a:rPr sz="1500" b="1" i="0">
+                <a:solidFill>
+                  <a:srgbClr val="0F2A43"/>
+                </a:solidFill>
+                <a:latin typeface="Calibri"/>
+              </a:rPr>
+              <a:t>Limits</a:t>
+            </a:r>
+          </a:p>
+        </p:txBody>
+      </p:sp>
+      <p:sp>
+        <p:nvSpPr>
+          <p:cNvPr id="11" name="TextBox 10"/>
+          <p:cNvSpPr txBox="1"/>
+          <p:nvPr/>
+        </p:nvSpPr>
+        <p:spPr>
+          <a:xfrm>
+            <a:off x="6903720" y="3703320"/>
+            <a:ext cx="4526280" cy="777240"/>
+          </a:xfrm>
+          <a:prstGeom prst="rect">
+            <a:avLst/>
+          </a:prstGeom>
+          <a:noFill/>
+        </p:spPr>
+        <p:txBody>
+          <a:bodyPr wrap="square" lIns="0" rIns="0" tIns="0" bIns="0" anchor="t">
+            <a:spAutoFit/>
+          </a:bodyPr>
+          <a:lstStyle/>
+          <a:p>
+            <a:pPr algn="l"/>
+            <a:r>
+              <a:rPr sz="1400" b="0" i="0">
+                <a:solidFill>
+                  <a:srgbClr val="1F2933"/>
+                </a:solidFill>
+                <a:latin typeface="Calibri"/>
+              </a:rPr>
+              <a:t>Asking prices, one website, 3,000 ads, few comparables for rare cars</a:t>
+            </a:r>
+          </a:p>
+        </p:txBody>
+      </p:sp>
+      <p:sp>
+        <p:nvSpPr>
+          <p:cNvPr id="12" name="Next steps"/>
+          <p:cNvSpPr/>
+          <p:nvPr/>
+        </p:nvSpPr>
+        <p:spPr>
+          <a:xfrm>
+            <a:off x="6675120" y="4709160"/>
+            <a:ext cx="4965192" cy="1463040"/>
+          </a:xfrm>
+          <a:prstGeom prst="roundRect">
+            <a:avLst>
+              <a:gd name="adj" fmla="val 6000"/>
+            </a:avLst>
+          </a:prstGeom>
+          <a:solidFill>
+            <a:srgbClr val="0F2A43"/>
+          </a:solidFill>
+          <a:ln>
+            <a:noFill/>
+          </a:ln>
+          <a:effectLst/>
+        </p:spPr>
+        <p:style>
+          <a:lnRef idx="1">
+            <a:schemeClr val="accent1"/>
+          </a:lnRef>
+          <a:fillRef idx="3">
+            <a:schemeClr val="accent1"/>
+          </a:fillRef>
+          <a:effectRef idx="2">
+            <a:schemeClr val="accent1"/>
+          </a:effectRef>
+          <a:fontRef idx="minor">
+            <a:schemeClr val="lt1"/>
+          </a:fontRef>
+        </p:style>
+        <p:txBody>
+          <a:bodyPr rtlCol="0" anchor="ctr"/>
+          <a:lstStyle/>
+          <a:p>
+            <a:pPr algn="ctr"/>
+          </a:p>
+        </p:txBody>
+      </p:sp>
+      <p:sp>
+        <p:nvSpPr>
+          <p:cNvPr id="13" name="Live demo link"/>
+          <p:cNvSpPr txBox="1"/>
+          <p:nvPr/>
+        </p:nvSpPr>
+        <p:spPr>
+          <a:xfrm>
+            <a:off x="548640" y="6263640"/>
+            <a:ext cx="11091672" cy="365760"/>
+          </a:xfrm>
+          <a:prstGeom prst="rect">
+            <a:avLst/>
+          </a:prstGeom>
+          <a:noFill/>
+        </p:spPr>
+        <p:txBody>
+          <a:bodyPr wrap="square" lIns="0" rIns="0" tIns="0" bIns="0" anchor="t">
+            <a:spAutoFit/>
+          </a:bodyPr>
+          <a:lstStyle/>
+          <a:p>
+            <a:pPr algn="l"/>
+            <a:r>
+              <a:rPr sz="1200" b="0" i="0">
+                <a:solidFill>
+                  <a:srgbClr val="5B6B7A"/>
+                </a:solidFill>
+                <a:latin typeface="Calibri"/>
+              </a:rPr>
+              <a:t>Live demo (Azure): https://car-price-app.bluemeadow-a6e43a1f.malaysiawest.azurecontainerapps.io</a:t>
+            </a:r>
+          </a:p>
+        </p:txBody>
+      </p:sp>
+      <p:sp>
+        <p:nvSpPr>
+          <p:cNvPr id="14" name="TextBox 13"/>
+          <p:cNvSpPr txBox="1"/>
+          <p:nvPr/>
+        </p:nvSpPr>
+        <p:spPr>
+          <a:xfrm>
+            <a:off x="6903720" y="4800600"/>
+            <a:ext cx="4526280" cy="365760"/>
+          </a:xfrm>
+          <a:prstGeom prst="rect">
+            <a:avLst/>
+          </a:prstGeom>
+          <a:noFill/>
+        </p:spPr>
+        <p:txBody>
+          <a:bodyPr wrap="square" lIns="0" rIns="0" tIns="0" bIns="0" anchor="t">
+            <a:spAutoFit/>
+          </a:bodyPr>
+          <a:lstStyle/>
+          <a:p>
+            <a:pPr algn="l"/>
+            <a:r>
               <a:rPr sz="1500" b="1" i="0">
                 <a:solidFill>
                   <a:srgbClr val="F4A83A"/>
@@ -5251,7 +6564,7 @@
                 </a:solidFill>
                 <a:latin typeface="Calibri"/>
               </a:rPr>
-              <a:t>Add time-series for market drift, more data sources, and MLOps deployment</a:t>
+              <a:t>Add time-series for market drift, more data sources, and prediction logging on Azure</a:t>
             </a:r>
           </a:p>
         </p:txBody>

</xml_diff>